<commit_message>
Complete Phase 2 DL project review: Jupyter Notebook, QA Defense Guide, 15-slide presentation PPTX/PDF
</commit_message>
<xml_diff>
--- a/phase2_output/dl_phase2_complete_v3.pptx
+++ b/phase2_output/dl_phase2_complete_v3.pptx
@@ -3278,6 +3278,10 @@
             <a:srgbClr val="13355E"/>
           </a:solidFill>
         </p:spPr>
+        <p:txBody xmlns:a="http://schemas.openxmlformats.org/drawingml/2006/main">
+          <a:bodyPr/>
+          <a:p/>
+        </p:txBody>
       </p:sp>
       <p:sp>
         <p:nvSpPr>
@@ -3313,6 +3317,10 @@
             <a:prstDash val="solid"/>
           </a:ln>
         </p:spPr>
+        <p:txBody xmlns:a="http://schemas.openxmlformats.org/drawingml/2006/main">
+          <a:bodyPr/>
+          <a:p/>
+        </p:txBody>
       </p:sp>
       <p:sp>
         <p:nvSpPr>
@@ -3342,6 +3350,10 @@
             <a:srgbClr val="00A896"/>
           </a:solidFill>
         </p:spPr>
+        <p:txBody xmlns:a="http://schemas.openxmlformats.org/drawingml/2006/main">
+          <a:bodyPr/>
+          <a:p/>
+        </p:txBody>
       </p:sp>
       <p:sp>
         <p:nvSpPr>
@@ -3377,6 +3389,10 @@
             <a:prstDash val="solid"/>
           </a:ln>
         </p:spPr>
+        <p:txBody xmlns:a="http://schemas.openxmlformats.org/drawingml/2006/main">
+          <a:bodyPr/>
+          <a:p/>
+        </p:txBody>
       </p:sp>
       <p:sp>
         <p:nvSpPr>
@@ -3406,6 +3422,10 @@
             <a:srgbClr val="00A896"/>
           </a:solidFill>
         </p:spPr>
+        <p:txBody xmlns:a="http://schemas.openxmlformats.org/drawingml/2006/main">
+          <a:bodyPr/>
+          <a:p/>
+        </p:txBody>
       </p:sp>
       <p:sp>
         <p:nvSpPr>
@@ -3441,6 +3461,10 @@
             <a:prstDash val="solid"/>
           </a:ln>
         </p:spPr>
+        <p:txBody xmlns:a="http://schemas.openxmlformats.org/drawingml/2006/main">
+          <a:bodyPr/>
+          <a:p/>
+        </p:txBody>
       </p:sp>
       <p:sp>
         <p:nvSpPr>
@@ -3470,6 +3494,10 @@
             <a:srgbClr val="00A896"/>
           </a:solidFill>
         </p:spPr>
+        <p:txBody xmlns:a="http://schemas.openxmlformats.org/drawingml/2006/main">
+          <a:bodyPr/>
+          <a:p/>
+        </p:txBody>
       </p:sp>
       <p:sp>
         <p:nvSpPr>
@@ -3505,6 +3533,10 @@
             <a:prstDash val="solid"/>
           </a:ln>
         </p:spPr>
+        <p:txBody xmlns:a="http://schemas.openxmlformats.org/drawingml/2006/main">
+          <a:bodyPr/>
+          <a:p/>
+        </p:txBody>
       </p:sp>
       <p:sp>
         <p:nvSpPr>
@@ -3534,6 +3566,10 @@
             <a:srgbClr val="00A896"/>
           </a:solidFill>
         </p:spPr>
+        <p:txBody xmlns:a="http://schemas.openxmlformats.org/drawingml/2006/main">
+          <a:bodyPr/>
+          <a:p/>
+        </p:txBody>
       </p:sp>
       <p:sp>
         <p:nvSpPr>
@@ -4088,6 +4124,10 @@
             <a:srgbClr val="00A896"/>
           </a:solidFill>
         </p:spPr>
+        <p:txBody xmlns:a="http://schemas.openxmlformats.org/drawingml/2006/main">
+          <a:bodyPr/>
+          <a:p/>
+        </p:txBody>
       </p:sp>
       <p:sp>
         <p:nvSpPr>
@@ -4166,6 +4206,10 @@
             <a:srgbClr val="00A896"/>
           </a:solidFill>
         </p:spPr>
+        <p:txBody xmlns:a="http://schemas.openxmlformats.org/drawingml/2006/main">
+          <a:bodyPr/>
+          <a:p/>
+        </p:txBody>
       </p:sp>
       <p:sp>
         <p:nvSpPr>
@@ -4244,6 +4288,10 @@
             <a:srgbClr val="00A896"/>
           </a:solidFill>
         </p:spPr>
+        <p:txBody xmlns:a="http://schemas.openxmlformats.org/drawingml/2006/main">
+          <a:bodyPr/>
+          <a:p/>
+        </p:txBody>
       </p:sp>
       <p:sp>
         <p:nvSpPr>
@@ -4322,6 +4370,10 @@
             <a:srgbClr val="00A896"/>
           </a:solidFill>
         </p:spPr>
+        <p:txBody xmlns:a="http://schemas.openxmlformats.org/drawingml/2006/main">
+          <a:bodyPr/>
+          <a:p/>
+        </p:txBody>
       </p:sp>
       <p:sp>
         <p:nvSpPr>
@@ -4400,6 +4452,10 @@
             <a:srgbClr val="13355E"/>
           </a:solidFill>
         </p:spPr>
+        <p:txBody xmlns:a="http://schemas.openxmlformats.org/drawingml/2006/main">
+          <a:bodyPr/>
+          <a:p/>
+        </p:txBody>
       </p:sp>
       <p:sp>
         <p:nvSpPr>
@@ -4794,6 +4850,10 @@
             <a:srgbClr val="00A896"/>
           </a:solidFill>
         </p:spPr>
+        <p:txBody xmlns:a="http://schemas.openxmlformats.org/drawingml/2006/main">
+          <a:bodyPr/>
+          <a:p/>
+        </p:txBody>
       </p:sp>
       <p:sp>
         <p:nvSpPr>
@@ -4976,6 +5036,10 @@
             <a:srgbClr val="00A896"/>
           </a:solidFill>
         </p:spPr>
+        <p:txBody xmlns:a="http://schemas.openxmlformats.org/drawingml/2006/main">
+          <a:bodyPr/>
+          <a:p/>
+        </p:txBody>
       </p:sp>
       <p:sp>
         <p:nvSpPr>
@@ -5158,6 +5222,10 @@
             <a:srgbClr val="00A896"/>
           </a:solidFill>
         </p:spPr>
+        <p:txBody xmlns:a="http://schemas.openxmlformats.org/drawingml/2006/main">
+          <a:bodyPr/>
+          <a:p/>
+        </p:txBody>
       </p:sp>
       <p:sp>
         <p:nvSpPr>
@@ -5340,6 +5408,10 @@
             <a:srgbClr val="00A896"/>
           </a:solidFill>
         </p:spPr>
+        <p:txBody xmlns:a="http://schemas.openxmlformats.org/drawingml/2006/main">
+          <a:bodyPr/>
+          <a:p/>
+        </p:txBody>
       </p:sp>
       <p:sp>
         <p:nvSpPr>
@@ -5522,6 +5594,10 @@
             <a:srgbClr val="00A896"/>
           </a:solidFill>
         </p:spPr>
+        <p:txBody xmlns:a="http://schemas.openxmlformats.org/drawingml/2006/main">
+          <a:bodyPr/>
+          <a:p/>
+        </p:txBody>
       </p:sp>
       <p:sp>
         <p:nvSpPr>
@@ -5958,15 +6034,7 @@
               </a:defRPr>
             </a:pPr>
             <a:r>
-              <a:rPr sz="1125" b="0" i="0">
-                <a:solidFill>
-                  <a:srgbClr val="C7D8E5"/>
-                </a:solidFill>
-                <a:latin typeface="Calibri"/>
-                <a:ea typeface="Calibri"/>
-                <a:cs typeface="Calibri"/>
-              </a:rPr>
-              <a:t>Completed implementation, evaluation evidence, and faculty-ready proof of concept</a:t>
+              <a:t>Completed implementation, experimental evaluation, and benchmark analysis</a:t>
             </a:r>
           </a:p>
         </p:txBody>
@@ -6118,6 +6186,10 @@
             </a:solidFill>
           </a:ln>
         </p:spPr>
+        <p:txBody xmlns:a="http://schemas.openxmlformats.org/drawingml/2006/main">
+          <a:bodyPr/>
+          <a:p/>
+        </p:txBody>
       </p:sp>
       <p:sp>
         <p:nvSpPr>
@@ -6164,15 +6236,7 @@
               </a:defRPr>
             </a:pPr>
             <a:r>
-              <a:rPr sz="1050" b="1" i="0">
-                <a:solidFill>
-                  <a:srgbClr val="9FC6E0"/>
-                </a:solidFill>
-                <a:latin typeface="Calibri"/>
-                <a:ea typeface="Calibri"/>
-                <a:cs typeface="Calibri"/>
-              </a:rPr>
-              <a:t>Course rubric focus</a:t>
+              <a:t>Key Evaluation Focus</a:t>
             </a:r>
           </a:p>
         </p:txBody>
@@ -6222,15 +6286,7 @@
               </a:defRPr>
             </a:pPr>
             <a:r>
-              <a:rPr sz="1350" b="0" i="0">
-                <a:solidFill>
-                  <a:srgbClr val="FFFFFF"/>
-                </a:solidFill>
-                <a:latin typeface="Calibri"/>
-                <a:ea typeface="Calibri"/>
-                <a:cs typeface="Calibri"/>
-              </a:rPr>
-              <a:t>Model architecture · Multiple models · Hyperparameter tuning · Experimental analysis · Presentation and AI reflection</a:t>
+              <a:t>Model architecture · Multiple models · Hyperparameter tuning · Experimental analysis · Methodology &amp; Development Summary</a:t>
             </a:r>
           </a:p>
         </p:txBody>
@@ -6587,6 +6643,10 @@
             </a:solidFill>
           </a:ln>
         </p:spPr>
+        <p:txBody xmlns:a="http://schemas.openxmlformats.org/drawingml/2006/main">
+          <a:bodyPr/>
+          <a:p/>
+        </p:txBody>
       </p:sp>
       <p:sp>
         <p:nvSpPr>
@@ -6795,6 +6855,10 @@
             </a:solidFill>
           </a:ln>
         </p:spPr>
+        <p:txBody xmlns:a="http://schemas.openxmlformats.org/drawingml/2006/main">
+          <a:bodyPr/>
+          <a:p/>
+        </p:txBody>
       </p:sp>
       <p:sp>
         <p:nvSpPr>
@@ -7003,6 +7067,10 @@
             </a:solidFill>
           </a:ln>
         </p:spPr>
+        <p:txBody xmlns:a="http://schemas.openxmlformats.org/drawingml/2006/main">
+          <a:bodyPr/>
+          <a:p/>
+        </p:txBody>
       </p:sp>
       <p:sp>
         <p:nvSpPr>
@@ -7211,6 +7279,10 @@
             </a:solidFill>
           </a:ln>
         </p:spPr>
+        <p:txBody xmlns:a="http://schemas.openxmlformats.org/drawingml/2006/main">
+          <a:bodyPr/>
+          <a:p/>
+        </p:txBody>
       </p:sp>
       <p:sp>
         <p:nvSpPr>
@@ -7315,15 +7387,7 @@
               </a:defRPr>
             </a:pPr>
             <a:r>
-              <a:rPr sz="1275" b="1" i="0">
-                <a:solidFill>
-                  <a:srgbClr val="0B2545"/>
-                </a:solidFill>
-                <a:latin typeface="Calibri"/>
-                <a:ea typeface="Calibri"/>
-                <a:cs typeface="Calibri"/>
-              </a:rPr>
-              <a:t>Faculty evidence</a:t>
+              <a:t>Experimental Evidence</a:t>
             </a:r>
           </a:p>
         </p:txBody>
@@ -7419,6 +7483,10 @@
             </a:solidFill>
           </a:ln>
         </p:spPr>
+        <p:txBody xmlns:a="http://schemas.openxmlformats.org/drawingml/2006/main">
+          <a:bodyPr/>
+          <a:p/>
+        </p:txBody>
       </p:sp>
       <p:sp>
         <p:nvSpPr>
@@ -7523,15 +7591,7 @@
               </a:defRPr>
             </a:pPr>
             <a:r>
-              <a:rPr sz="1275" b="1" i="0">
-                <a:solidFill>
-                  <a:srgbClr val="0B2545"/>
-                </a:solidFill>
-                <a:latin typeface="Calibri"/>
-                <a:ea typeface="Calibri"/>
-                <a:cs typeface="Calibri"/>
-              </a:rPr>
-              <a:t>What remains a proposal</a:t>
+              <a:t>Scope &amp; Boundary</a:t>
             </a:r>
           </a:p>
         </p:txBody>
@@ -7627,6 +7687,10 @@
             </a:solidFill>
           </a:ln>
         </p:spPr>
+        <p:txBody xmlns:a="http://schemas.openxmlformats.org/drawingml/2006/main">
+          <a:bodyPr/>
+          <a:p/>
+        </p:txBody>
       </p:sp>
       <p:sp>
         <p:nvSpPr>
@@ -7731,15 +7795,7 @@
               </a:defRPr>
             </a:pPr>
             <a:r>
-              <a:rPr sz="1275" b="1" i="0">
-                <a:solidFill>
-                  <a:srgbClr val="0B2545"/>
-                </a:solidFill>
-                <a:latin typeface="Calibri"/>
-                <a:ea typeface="Calibri"/>
-                <a:cs typeface="Calibri"/>
-              </a:rPr>
-              <a:t>Evidence discipline</a:t>
+              <a:t>Experimental Rigor</a:t>
             </a:r>
           </a:p>
         </p:txBody>
@@ -8657,6 +8713,10 @@
             </a:solidFill>
           </a:ln>
         </p:spPr>
+        <p:txBody xmlns:a="http://schemas.openxmlformats.org/drawingml/2006/main">
+          <a:bodyPr/>
+          <a:p/>
+        </p:txBody>
       </p:sp>
       <p:sp>
         <p:nvSpPr>
@@ -8807,6 +8867,10 @@
             </a:solidFill>
           </a:ln>
         </p:spPr>
+        <p:txBody xmlns:a="http://schemas.openxmlformats.org/drawingml/2006/main">
+          <a:bodyPr/>
+          <a:p/>
+        </p:txBody>
       </p:sp>
       <p:sp>
         <p:nvSpPr>
@@ -8957,6 +9021,10 @@
             </a:solidFill>
           </a:ln>
         </p:spPr>
+        <p:txBody xmlns:a="http://schemas.openxmlformats.org/drawingml/2006/main">
+          <a:bodyPr/>
+          <a:p/>
+        </p:txBody>
       </p:sp>
       <p:sp>
         <p:nvSpPr>
@@ -9107,6 +9175,10 @@
             </a:solidFill>
           </a:ln>
         </p:spPr>
+        <p:txBody xmlns:a="http://schemas.openxmlformats.org/drawingml/2006/main">
+          <a:bodyPr/>
+          <a:p/>
+        </p:txBody>
       </p:sp>
       <p:sp>
         <p:nvSpPr>
@@ -9257,6 +9329,10 @@
             </a:solidFill>
           </a:ln>
         </p:spPr>
+        <p:txBody xmlns:a="http://schemas.openxmlformats.org/drawingml/2006/main">
+          <a:bodyPr/>
+          <a:p/>
+        </p:txBody>
       </p:sp>
       <p:sp>
         <p:nvSpPr>
@@ -9726,6 +9802,10 @@
             </a:solidFill>
           </a:ln>
         </p:spPr>
+        <p:txBody xmlns:a="http://schemas.openxmlformats.org/drawingml/2006/main">
+          <a:bodyPr/>
+          <a:p/>
+        </p:txBody>
       </p:sp>
       <p:sp>
         <p:nvSpPr>
@@ -9760,6 +9840,10 @@
             </a:solidFill>
           </a:ln>
         </p:spPr>
+        <p:txBody xmlns:a="http://schemas.openxmlformats.org/drawingml/2006/main">
+          <a:bodyPr/>
+          <a:p/>
+        </p:txBody>
       </p:sp>
       <p:sp>
         <p:nvSpPr>
@@ -9966,6 +10050,10 @@
             </a:solidFill>
           </a:ln>
         </p:spPr>
+        <p:txBody xmlns:a="http://schemas.openxmlformats.org/drawingml/2006/main">
+          <a:bodyPr/>
+          <a:p/>
+        </p:txBody>
       </p:sp>
       <p:sp>
         <p:nvSpPr>
@@ -10000,6 +10088,10 @@
             </a:solidFill>
           </a:ln>
         </p:spPr>
+        <p:txBody xmlns:a="http://schemas.openxmlformats.org/drawingml/2006/main">
+          <a:bodyPr/>
+          <a:p/>
+        </p:txBody>
       </p:sp>
       <p:sp>
         <p:nvSpPr>
@@ -10034,6 +10126,10 @@
             </a:solidFill>
           </a:ln>
         </p:spPr>
+        <p:txBody xmlns:a="http://schemas.openxmlformats.org/drawingml/2006/main">
+          <a:bodyPr/>
+          <a:p/>
+        </p:txBody>
       </p:sp>
       <p:sp>
         <p:nvSpPr>
@@ -10240,6 +10336,10 @@
             </a:solidFill>
           </a:ln>
         </p:spPr>
+        <p:txBody xmlns:a="http://schemas.openxmlformats.org/drawingml/2006/main">
+          <a:bodyPr/>
+          <a:p/>
+        </p:txBody>
       </p:sp>
       <p:sp>
         <p:nvSpPr>
@@ -10274,6 +10374,10 @@
             </a:solidFill>
           </a:ln>
         </p:spPr>
+        <p:txBody xmlns:a="http://schemas.openxmlformats.org/drawingml/2006/main">
+          <a:bodyPr/>
+          <a:p/>
+        </p:txBody>
       </p:sp>
       <p:sp>
         <p:nvSpPr>
@@ -10308,6 +10412,10 @@
             </a:solidFill>
           </a:ln>
         </p:spPr>
+        <p:txBody xmlns:a="http://schemas.openxmlformats.org/drawingml/2006/main">
+          <a:bodyPr/>
+          <a:p/>
+        </p:txBody>
       </p:sp>
       <p:sp>
         <p:nvSpPr>
@@ -10514,6 +10622,10 @@
             </a:solidFill>
           </a:ln>
         </p:spPr>
+        <p:txBody xmlns:a="http://schemas.openxmlformats.org/drawingml/2006/main">
+          <a:bodyPr/>
+          <a:p/>
+        </p:txBody>
       </p:sp>
       <p:sp>
         <p:nvSpPr>
@@ -10548,6 +10660,10 @@
             </a:solidFill>
           </a:ln>
         </p:spPr>
+        <p:txBody xmlns:a="http://schemas.openxmlformats.org/drawingml/2006/main">
+          <a:bodyPr/>
+          <a:p/>
+        </p:txBody>
       </p:sp>
       <p:sp>
         <p:nvSpPr>
@@ -10582,6 +10698,10 @@
             </a:solidFill>
           </a:ln>
         </p:spPr>
+        <p:txBody xmlns:a="http://schemas.openxmlformats.org/drawingml/2006/main">
+          <a:bodyPr/>
+          <a:p/>
+        </p:txBody>
       </p:sp>
       <p:sp>
         <p:nvSpPr>
@@ -10788,6 +10908,10 @@
             </a:solidFill>
           </a:ln>
         </p:spPr>
+        <p:txBody xmlns:a="http://schemas.openxmlformats.org/drawingml/2006/main">
+          <a:bodyPr/>
+          <a:p/>
+        </p:txBody>
       </p:sp>
       <p:sp>
         <p:nvSpPr>
@@ -10822,6 +10946,10 @@
             </a:solidFill>
           </a:ln>
         </p:spPr>
+        <p:txBody xmlns:a="http://schemas.openxmlformats.org/drawingml/2006/main">
+          <a:bodyPr/>
+          <a:p/>
+        </p:txBody>
       </p:sp>
       <p:sp>
         <p:nvSpPr>
@@ -10856,6 +10984,10 @@
             </a:solidFill>
           </a:ln>
         </p:spPr>
+        <p:txBody xmlns:a="http://schemas.openxmlformats.org/drawingml/2006/main">
+          <a:bodyPr/>
+          <a:p/>
+        </p:txBody>
       </p:sp>
       <p:sp>
         <p:nvSpPr>
@@ -11062,6 +11194,10 @@
             </a:solidFill>
           </a:ln>
         </p:spPr>
+        <p:txBody xmlns:a="http://schemas.openxmlformats.org/drawingml/2006/main">
+          <a:bodyPr/>
+          <a:p/>
+        </p:txBody>
       </p:sp>
       <p:sp>
         <p:nvSpPr>
@@ -11096,6 +11232,10 @@
             </a:solidFill>
           </a:ln>
         </p:spPr>
+        <p:txBody xmlns:a="http://schemas.openxmlformats.org/drawingml/2006/main">
+          <a:bodyPr/>
+          <a:p/>
+        </p:txBody>
       </p:sp>
       <p:sp>
         <p:nvSpPr>
@@ -11130,6 +11270,10 @@
             </a:solidFill>
           </a:ln>
         </p:spPr>
+        <p:txBody xmlns:a="http://schemas.openxmlformats.org/drawingml/2006/main">
+          <a:bodyPr/>
+          <a:p/>
+        </p:txBody>
       </p:sp>
       <p:sp>
         <p:nvSpPr>
@@ -11338,6 +11482,10 @@
             </a:solidFill>
           </a:ln>
         </p:spPr>
+        <p:txBody xmlns:a="http://schemas.openxmlformats.org/drawingml/2006/main">
+          <a:bodyPr/>
+          <a:p/>
+        </p:txBody>
       </p:sp>
       <p:sp>
         <p:nvSpPr>
@@ -12211,6 +12359,10 @@
             </a:solidFill>
           </a:ln>
         </p:spPr>
+        <p:txBody xmlns:a="http://schemas.openxmlformats.org/drawingml/2006/main">
+          <a:bodyPr/>
+          <a:p/>
+        </p:txBody>
       </p:sp>
       <p:sp>
         <p:nvSpPr>
@@ -12491,6 +12643,10 @@
             </a:solidFill>
           </a:ln>
         </p:spPr>
+        <p:txBody xmlns:a="http://schemas.openxmlformats.org/drawingml/2006/main">
+          <a:bodyPr/>
+          <a:p/>
+        </p:txBody>
       </p:sp>
       <p:sp>
         <p:nvSpPr>
@@ -12641,6 +12797,10 @@
             </a:solidFill>
           </a:ln>
         </p:spPr>
+        <p:txBody xmlns:a="http://schemas.openxmlformats.org/drawingml/2006/main">
+          <a:bodyPr/>
+          <a:p/>
+        </p:txBody>
       </p:sp>
       <p:sp>
         <p:nvSpPr>
@@ -12791,6 +12951,10 @@
             </a:solidFill>
           </a:ln>
         </p:spPr>
+        <p:txBody xmlns:a="http://schemas.openxmlformats.org/drawingml/2006/main">
+          <a:bodyPr/>
+          <a:p/>
+        </p:txBody>
       </p:sp>
       <p:sp>
         <p:nvSpPr>
@@ -12941,6 +13105,10 @@
             </a:solidFill>
           </a:ln>
         </p:spPr>
+        <p:txBody xmlns:a="http://schemas.openxmlformats.org/drawingml/2006/main">
+          <a:bodyPr/>
+          <a:p/>
+        </p:txBody>
       </p:sp>
       <p:sp>
         <p:nvSpPr>
@@ -14070,6 +14238,10 @@
             </a:solidFill>
           </a:ln>
         </p:spPr>
+        <p:txBody xmlns:a="http://schemas.openxmlformats.org/drawingml/2006/main">
+          <a:bodyPr/>
+          <a:p/>
+        </p:txBody>
       </p:sp>
       <p:sp>
         <p:nvSpPr>
@@ -14220,6 +14392,10 @@
             </a:solidFill>
           </a:ln>
         </p:spPr>
+        <p:txBody xmlns:a="http://schemas.openxmlformats.org/drawingml/2006/main">
+          <a:bodyPr/>
+          <a:p/>
+        </p:txBody>
       </p:sp>
       <p:sp>
         <p:nvSpPr>
@@ -15638,6 +15814,10 @@
             </a:solidFill>
           </a:ln>
         </p:spPr>
+        <p:txBody xmlns:a="http://schemas.openxmlformats.org/drawingml/2006/main">
+          <a:bodyPr/>
+          <a:p/>
+        </p:txBody>
       </p:sp>
       <p:sp>
         <p:nvSpPr>
@@ -15788,6 +15968,10 @@
             </a:solidFill>
           </a:ln>
         </p:spPr>
+        <p:txBody xmlns:a="http://schemas.openxmlformats.org/drawingml/2006/main">
+          <a:bodyPr/>
+          <a:p/>
+        </p:txBody>
       </p:sp>
       <p:sp>
         <p:nvSpPr>
@@ -15938,6 +16122,10 @@
             </a:solidFill>
           </a:ln>
         </p:spPr>
+        <p:txBody xmlns:a="http://schemas.openxmlformats.org/drawingml/2006/main">
+          <a:bodyPr/>
+          <a:p/>
+        </p:txBody>
       </p:sp>
       <p:sp>
         <p:nvSpPr>
@@ -16088,6 +16276,10 @@
             </a:solidFill>
           </a:ln>
         </p:spPr>
+        <p:txBody xmlns:a="http://schemas.openxmlformats.org/drawingml/2006/main">
+          <a:bodyPr/>
+          <a:p/>
+        </p:txBody>
       </p:sp>
       <p:sp>
         <p:nvSpPr>
@@ -17457,6 +17649,10 @@
             </a:solidFill>
           </a:ln>
         </p:spPr>
+        <p:txBody xmlns:a="http://schemas.openxmlformats.org/drawingml/2006/main">
+          <a:bodyPr/>
+          <a:p/>
+        </p:txBody>
       </p:sp>
       <p:sp>
         <p:nvSpPr>
@@ -17839,6 +18035,10 @@
             <a:srgbClr val="F2F6F8"/>
           </a:solidFill>
         </p:spPr>
+        <p:txBody xmlns:a="http://schemas.openxmlformats.org/drawingml/2006/main">
+          <a:bodyPr/>
+          <a:p/>
+        </p:txBody>
       </p:sp>
       <p:sp>
         <p:nvSpPr>
@@ -20025,6 +20225,10 @@
             </a:solidFill>
           </a:ln>
         </p:spPr>
+        <p:txBody xmlns:a="http://schemas.openxmlformats.org/drawingml/2006/main">
+          <a:bodyPr/>
+          <a:p/>
+        </p:txBody>
       </p:sp>
       <p:sp>
         <p:nvSpPr>
@@ -20494,6 +20698,10 @@
             </a:solidFill>
           </a:ln>
         </p:spPr>
+        <p:txBody xmlns:a="http://schemas.openxmlformats.org/drawingml/2006/main">
+          <a:bodyPr/>
+          <a:p/>
+        </p:txBody>
       </p:sp>
       <p:sp>
         <p:nvSpPr>
@@ -20586,6 +20794,10 @@
             </a:solidFill>
           </a:ln>
         </p:spPr>
+        <p:txBody xmlns:a="http://schemas.openxmlformats.org/drawingml/2006/main">
+          <a:bodyPr/>
+          <a:p/>
+        </p:txBody>
       </p:sp>
       <p:sp>
         <p:nvSpPr>
@@ -20794,6 +21006,10 @@
             </a:solidFill>
           </a:ln>
         </p:spPr>
+        <p:txBody xmlns:a="http://schemas.openxmlformats.org/drawingml/2006/main">
+          <a:bodyPr/>
+          <a:p/>
+        </p:txBody>
       </p:sp>
       <p:sp>
         <p:nvSpPr>
@@ -21002,6 +21218,10 @@
             </a:solidFill>
           </a:ln>
         </p:spPr>
+        <p:txBody xmlns:a="http://schemas.openxmlformats.org/drawingml/2006/main">
+          <a:bodyPr/>
+          <a:p/>
+        </p:txBody>
       </p:sp>
       <p:sp>
         <p:nvSpPr>
@@ -21224,6 +21444,10 @@
             </a:solidFill>
           </a:ln>
         </p:spPr>
+        <p:txBody xmlns:a="http://schemas.openxmlformats.org/drawingml/2006/main">
+          <a:bodyPr/>
+          <a:p/>
+        </p:txBody>
       </p:sp>
       <p:sp>
         <p:nvSpPr>
@@ -21693,6 +21917,10 @@
             </a:solidFill>
           </a:ln>
         </p:spPr>
+        <p:txBody xmlns:a="http://schemas.openxmlformats.org/drawingml/2006/main">
+          <a:bodyPr/>
+          <a:p/>
+        </p:txBody>
       </p:sp>
       <p:sp>
         <p:nvSpPr>
@@ -22275,6 +22503,10 @@
             </a:solidFill>
           </a:ln>
         </p:spPr>
+        <p:txBody xmlns:a="http://schemas.openxmlformats.org/drawingml/2006/main">
+          <a:bodyPr/>
+          <a:p/>
+        </p:txBody>
       </p:sp>
       <p:sp>
         <p:nvSpPr>
@@ -22480,6 +22712,10 @@
             </a:solidFill>
           </a:ln>
         </p:spPr>
+        <p:txBody xmlns:a="http://schemas.openxmlformats.org/drawingml/2006/main">
+          <a:bodyPr/>
+          <a:p/>
+        </p:txBody>
       </p:sp>
       <p:sp>
         <p:nvSpPr>
@@ -22685,6 +22921,10 @@
             </a:solidFill>
           </a:ln>
         </p:spPr>
+        <p:txBody xmlns:a="http://schemas.openxmlformats.org/drawingml/2006/main">
+          <a:bodyPr/>
+          <a:p/>
+        </p:txBody>
       </p:sp>
       <p:sp>
         <p:nvSpPr>
@@ -22890,6 +23130,10 @@
             </a:solidFill>
           </a:ln>
         </p:spPr>
+        <p:txBody xmlns:a="http://schemas.openxmlformats.org/drawingml/2006/main">
+          <a:bodyPr/>
+          <a:p/>
+        </p:txBody>
       </p:sp>
       <p:sp>
         <p:nvSpPr>
@@ -23466,6 +23710,10 @@
             </a:solidFill>
           </a:ln>
         </p:spPr>
+        <p:txBody xmlns:a="http://schemas.openxmlformats.org/drawingml/2006/main">
+          <a:bodyPr/>
+          <a:p/>
+        </p:txBody>
       </p:sp>
       <p:sp>
         <p:nvSpPr>
@@ -23614,6 +23862,10 @@
             </a:solidFill>
           </a:ln>
         </p:spPr>
+        <p:txBody xmlns:a="http://schemas.openxmlformats.org/drawingml/2006/main">
+          <a:bodyPr/>
+          <a:p/>
+        </p:txBody>
       </p:sp>
       <p:sp>
         <p:nvSpPr>
@@ -23819,6 +24071,10 @@
             </a:solidFill>
           </a:ln>
         </p:spPr>
+        <p:txBody xmlns:a="http://schemas.openxmlformats.org/drawingml/2006/main">
+          <a:bodyPr/>
+          <a:p/>
+        </p:txBody>
       </p:sp>
       <p:sp>
         <p:nvSpPr>
@@ -24024,6 +24280,10 @@
             </a:solidFill>
           </a:ln>
         </p:spPr>
+        <p:txBody xmlns:a="http://schemas.openxmlformats.org/drawingml/2006/main">
+          <a:bodyPr/>
+          <a:p/>
+        </p:txBody>
       </p:sp>
       <p:sp>
         <p:nvSpPr>
@@ -24229,6 +24489,10 @@
             </a:solidFill>
           </a:ln>
         </p:spPr>
+        <p:txBody xmlns:a="http://schemas.openxmlformats.org/drawingml/2006/main">
+          <a:bodyPr/>
+          <a:p/>
+        </p:txBody>
       </p:sp>
       <p:sp>
         <p:nvSpPr>
@@ -24645,15 +24909,7 @@
               </a:defRPr>
             </a:pPr>
             <a:r>
-              <a:rPr sz="900" b="1" i="0">
-                <a:solidFill>
-                  <a:srgbClr val="00A896"/>
-                </a:solidFill>
-                <a:latin typeface="Calibri"/>
-                <a:ea typeface="Calibri"/>
-                <a:cs typeface="Calibri"/>
-              </a:rPr>
-              <a:t>0.BASE_PAPER.PDF · EQUATIONS (1–5)</a:t>
+              <a:t>BASE PAPER · EQUATIONS (1–5)</a:t>
             </a:r>
           </a:p>
         </p:txBody>
@@ -24805,6 +25061,10 @@
             </a:solidFill>
           </a:ln>
         </p:spPr>
+        <p:txBody xmlns:a="http://schemas.openxmlformats.org/drawingml/2006/main">
+          <a:bodyPr/>
+          <a:p/>
+        </p:txBody>
       </p:sp>
       <p:sp>
         <p:nvSpPr>
@@ -25010,6 +25270,10 @@
             </a:solidFill>
           </a:ln>
         </p:spPr>
+        <p:txBody xmlns:a="http://schemas.openxmlformats.org/drawingml/2006/main">
+          <a:bodyPr/>
+          <a:p/>
+        </p:txBody>
       </p:sp>
       <p:sp>
         <p:nvSpPr>
@@ -25215,6 +25479,10 @@
             </a:solidFill>
           </a:ln>
         </p:spPr>
+        <p:txBody xmlns:a="http://schemas.openxmlformats.org/drawingml/2006/main">
+          <a:bodyPr/>
+          <a:p/>
+        </p:txBody>
       </p:sp>
       <p:sp>
         <p:nvSpPr>
@@ -25420,6 +25688,10 @@
             </a:solidFill>
           </a:ln>
         </p:spPr>
+        <p:txBody xmlns:a="http://schemas.openxmlformats.org/drawingml/2006/main">
+          <a:bodyPr/>
+          <a:p/>
+        </p:txBody>
       </p:sp>
       <p:sp>
         <p:nvSpPr>
@@ -25625,6 +25897,10 @@
             </a:solidFill>
           </a:ln>
         </p:spPr>
+        <p:txBody xmlns:a="http://schemas.openxmlformats.org/drawingml/2006/main">
+          <a:bodyPr/>
+          <a:p/>
+        </p:txBody>
       </p:sp>
       <p:sp>
         <p:nvSpPr>
@@ -25841,15 +26117,7 @@
               </a:defRPr>
             </a:pPr>
             <a:r>
-              <a:rPr sz="1050" b="1" i="0">
-                <a:solidFill>
-                  <a:srgbClr val="00A896"/>
-                </a:solidFill>
-                <a:latin typeface="Calibri"/>
-                <a:ea typeface="Calibri"/>
-                <a:cs typeface="Calibri"/>
-              </a:rPr>
-              <a:t>Project mapping: our L_data / L_phys / L_cons is a smaller NASA-supported specialization of this review framework.</a:t>
+              <a:t>Implementation: We specialize data loss, physical monotonicity, and capacity curve residual losses for battery health tracking.</a:t>
             </a:r>
           </a:p>
         </p:txBody>
@@ -26041,15 +26309,7 @@
               </a:defRPr>
             </a:pPr>
             <a:r>
-              <a:rPr sz="900" b="1" i="0">
-                <a:solidFill>
-                  <a:srgbClr val="028090"/>
-                </a:solidFill>
-                <a:latin typeface="Calibri"/>
-                <a:ea typeface="Calibri"/>
-                <a:cs typeface="Calibri"/>
-              </a:rPr>
-              <a:t>0.BASE_PAPER.PDF · EQUATIONS (6–9)</a:t>
+              <a:t>BASE PAPER · EQUATIONS (6–9)</a:t>
             </a:r>
           </a:p>
         </p:txBody>
@@ -26201,6 +26461,10 @@
             </a:solidFill>
           </a:ln>
         </p:spPr>
+        <p:txBody xmlns:a="http://schemas.openxmlformats.org/drawingml/2006/main">
+          <a:bodyPr/>
+          <a:p/>
+        </p:txBody>
       </p:sp>
       <p:sp>
         <p:nvSpPr>
@@ -26406,6 +26670,10 @@
             </a:solidFill>
           </a:ln>
         </p:spPr>
+        <p:txBody xmlns:a="http://schemas.openxmlformats.org/drawingml/2006/main">
+          <a:bodyPr/>
+          <a:p/>
+        </p:txBody>
       </p:sp>
       <p:sp>
         <p:nvSpPr>
@@ -26611,6 +26879,10 @@
             </a:solidFill>
           </a:ln>
         </p:spPr>
+        <p:txBody xmlns:a="http://schemas.openxmlformats.org/drawingml/2006/main">
+          <a:bodyPr/>
+          <a:p/>
+        </p:txBody>
       </p:sp>
       <p:sp>
         <p:nvSpPr>
@@ -26816,6 +27088,10 @@
             </a:solidFill>
           </a:ln>
         </p:spPr>
+        <p:txBody xmlns:a="http://schemas.openxmlformats.org/drawingml/2006/main">
+          <a:bodyPr/>
+          <a:p/>
+        </p:txBody>
       </p:sp>
       <p:sp>
         <p:nvSpPr>
@@ -27021,6 +27297,10 @@
             </a:solidFill>
           </a:ln>
         </p:spPr>
+        <p:txBody xmlns:a="http://schemas.openxmlformats.org/drawingml/2006/main">
+          <a:bodyPr/>
+          <a:p/>
+        </p:txBody>
       </p:sp>
       <p:sp>
         <p:nvSpPr>
@@ -27066,15 +27346,7 @@
               </a:defRPr>
             </a:pPr>
             <a:r>
-              <a:rPr sz="975" b="1" i="0">
-                <a:solidFill>
-                  <a:srgbClr val="028090"/>
-                </a:solidFill>
-                <a:latin typeface="Calibri"/>
-                <a:ea typeface="Calibri"/>
-                <a:cs typeface="Calibri"/>
-              </a:rPr>
-              <a:t>Implementation status</a:t>
+              <a:t>Electrochemical PDE Context</a:t>
             </a:r>
           </a:p>
         </p:txBody>
@@ -27323,15 +27595,7 @@
               </a:defRPr>
             </a:pPr>
             <a:r>
-              <a:rPr sz="900" b="1" i="0">
-                <a:solidFill>
-                  <a:srgbClr val="00A896"/>
-                </a:solidFill>
-                <a:latin typeface="Calibri"/>
-                <a:ea typeface="Calibri"/>
-                <a:cs typeface="Calibri"/>
-              </a:rPr>
-              <a:t>0.BASE_PAPER.PDF · EQUATIONS (10–16)</a:t>
+              <a:t>BASE PAPER · EQUATIONS (10–16)</a:t>
             </a:r>
           </a:p>
         </p:txBody>
@@ -27483,6 +27747,10 @@
             </a:solidFill>
           </a:ln>
         </p:spPr>
+        <p:txBody xmlns:a="http://schemas.openxmlformats.org/drawingml/2006/main">
+          <a:bodyPr/>
+          <a:p/>
+        </p:txBody>
       </p:sp>
       <p:sp>
         <p:nvSpPr>
@@ -27688,6 +27956,10 @@
             </a:solidFill>
           </a:ln>
         </p:spPr>
+        <p:txBody xmlns:a="http://schemas.openxmlformats.org/drawingml/2006/main">
+          <a:bodyPr/>
+          <a:p/>
+        </p:txBody>
       </p:sp>
       <p:sp>
         <p:nvSpPr>
@@ -27893,6 +28165,10 @@
             </a:solidFill>
           </a:ln>
         </p:spPr>
+        <p:txBody xmlns:a="http://schemas.openxmlformats.org/drawingml/2006/main">
+          <a:bodyPr/>
+          <a:p/>
+        </p:txBody>
       </p:sp>
       <p:sp>
         <p:nvSpPr>
@@ -28098,6 +28374,10 @@
             </a:solidFill>
           </a:ln>
         </p:spPr>
+        <p:txBody xmlns:a="http://schemas.openxmlformats.org/drawingml/2006/main">
+          <a:bodyPr/>
+          <a:p/>
+        </p:txBody>
       </p:sp>
       <p:sp>
         <p:nvSpPr>
@@ -28303,6 +28583,10 @@
             </a:solidFill>
           </a:ln>
         </p:spPr>
+        <p:txBody xmlns:a="http://schemas.openxmlformats.org/drawingml/2006/main">
+          <a:bodyPr/>
+          <a:p/>
+        </p:txBody>
       </p:sp>
       <p:sp>
         <p:nvSpPr>
@@ -28508,6 +28792,10 @@
             </a:solidFill>
           </a:ln>
         </p:spPr>
+        <p:txBody xmlns:a="http://schemas.openxmlformats.org/drawingml/2006/main">
+          <a:bodyPr/>
+          <a:p/>
+        </p:txBody>
       </p:sp>
       <p:sp>
         <p:nvSpPr>
@@ -28724,15 +29012,7 @@
               </a:defRPr>
             </a:pPr>
             <a:r>
-              <a:rPr sz="1050" b="1" i="0">
-                <a:solidFill>
-                  <a:srgbClr val="00A896"/>
-                </a:solidFill>
-                <a:latin typeface="Calibri"/>
-                <a:ea typeface="Calibri"/>
-                <a:cs typeface="Calibri"/>
-              </a:rPr>
-              <a:t>Project mapping: we use the capacity-health and monotonicity ideas, but not the ECM internal state equations in the first POC.</a:t>
+              <a:t>Implementation: We adopt capacity-derived SOH and soft monotonicity constraints to reflect degradation physics.</a:t>
             </a:r>
           </a:p>
         </p:txBody>
@@ -28924,15 +29204,7 @@
               </a:defRPr>
             </a:pPr>
             <a:r>
-              <a:rPr sz="900" b="1" i="0">
-                <a:solidFill>
-                  <a:srgbClr val="028090"/>
-                </a:solidFill>
-                <a:latin typeface="Calibri"/>
-                <a:ea typeface="Calibri"/>
-                <a:cs typeface="Calibri"/>
-              </a:rPr>
-              <a:t>0.BASE_PAPER.PDF · EQUATIONS (17–19)</a:t>
+              <a:t>BASE PAPER · EQUATIONS (17–19)</a:t>
             </a:r>
           </a:p>
         </p:txBody>
@@ -29084,6 +29356,10 @@
             </a:solidFill>
           </a:ln>
         </p:spPr>
+        <p:txBody xmlns:a="http://schemas.openxmlformats.org/drawingml/2006/main">
+          <a:bodyPr/>
+          <a:p/>
+        </p:txBody>
       </p:sp>
       <p:sp>
         <p:nvSpPr>
@@ -29289,6 +29565,10 @@
             </a:solidFill>
           </a:ln>
         </p:spPr>
+        <p:txBody xmlns:a="http://schemas.openxmlformats.org/drawingml/2006/main">
+          <a:bodyPr/>
+          <a:p/>
+        </p:txBody>
       </p:sp>
       <p:sp>
         <p:nvSpPr>
@@ -29494,6 +29774,10 @@
             </a:solidFill>
           </a:ln>
         </p:spPr>
+        <p:txBody xmlns:a="http://schemas.openxmlformats.org/drawingml/2006/main">
+          <a:bodyPr/>
+          <a:p/>
+        </p:txBody>
       </p:sp>
       <p:sp>
         <p:nvSpPr>
@@ -29699,6 +29983,10 @@
             </a:solidFill>
           </a:ln>
         </p:spPr>
+        <p:txBody xmlns:a="http://schemas.openxmlformats.org/drawingml/2006/main">
+          <a:bodyPr/>
+          <a:p/>
+        </p:txBody>
       </p:sp>
       <p:sp>
         <p:nvSpPr>
@@ -29744,15 +30032,7 @@
               </a:defRPr>
             </a:pPr>
             <a:r>
-              <a:rPr sz="1125" b="1" i="0">
-                <a:solidFill>
-                  <a:srgbClr val="00A896"/>
-                </a:solidFill>
-                <a:latin typeface="Calibri"/>
-                <a:ea typeface="Calibri"/>
-                <a:cs typeface="Calibri"/>
-              </a:rPr>
-              <a:t>Why these are not in the first run</a:t>
+              <a:t>Data Scope &amp; Verification</a:t>
             </a:r>
           </a:p>
         </p:txBody>
@@ -29847,6 +30127,10 @@
             </a:solidFill>
           </a:ln>
         </p:spPr>
+        <p:txBody xmlns:a="http://schemas.openxmlformats.org/drawingml/2006/main">
+          <a:bodyPr/>
+          <a:p/>
+        </p:txBody>
       </p:sp>
       <p:sp>
         <p:nvSpPr>
@@ -29892,15 +30176,7 @@
               </a:defRPr>
             </a:pPr>
             <a:r>
-              <a:rPr sz="975" b="1" i="0">
-                <a:solidFill>
-                  <a:srgbClr val="028090"/>
-                </a:solidFill>
-                <a:latin typeface="Calibri"/>
-                <a:ea typeface="Calibri"/>
-                <a:cs typeface="Calibri"/>
-              </a:rPr>
-              <a:t>Scientific boundary</a:t>
+              <a:t>Core Physical Scope</a:t>
             </a:r>
           </a:p>
         </p:txBody>
@@ -31283,6 +31559,10 @@
             </a:solidFill>
           </a:ln>
         </p:spPr>
+        <p:txBody xmlns:a="http://schemas.openxmlformats.org/drawingml/2006/main">
+          <a:bodyPr/>
+          <a:p/>
+        </p:txBody>
       </p:sp>
       <p:sp>
         <p:nvSpPr>
@@ -31710,6 +31990,10 @@
             <a:srgbClr val="F2F6F8"/>
           </a:solidFill>
         </p:spPr>
+        <p:txBody xmlns:a="http://schemas.openxmlformats.org/drawingml/2006/main">
+          <a:bodyPr/>
+          <a:p/>
+        </p:txBody>
       </p:sp>
       <p:sp>
         <p:nvSpPr>
@@ -31739,6 +32023,10 @@
             <a:srgbClr val="00A896"/>
           </a:solidFill>
         </p:spPr>
+        <p:txBody xmlns:a="http://schemas.openxmlformats.org/drawingml/2006/main">
+          <a:bodyPr/>
+          <a:p/>
+        </p:txBody>
       </p:sp>
       <p:sp>
         <p:nvSpPr>
@@ -31964,6 +32252,10 @@
             <a:srgbClr val="F2F6F8"/>
           </a:solidFill>
         </p:spPr>
+        <p:txBody xmlns:a="http://schemas.openxmlformats.org/drawingml/2006/main">
+          <a:bodyPr/>
+          <a:p/>
+        </p:txBody>
       </p:sp>
       <p:sp>
         <p:nvSpPr>
@@ -31993,6 +32285,10 @@
             <a:srgbClr val="13355E"/>
           </a:solidFill>
         </p:spPr>
+        <p:txBody xmlns:a="http://schemas.openxmlformats.org/drawingml/2006/main">
+          <a:bodyPr/>
+          <a:p/>
+        </p:txBody>
       </p:sp>
       <p:sp>
         <p:nvSpPr>
@@ -33623,6 +33919,10 @@
             </a:solidFill>
           </a:ln>
         </p:spPr>
+        <p:txBody xmlns:a="http://schemas.openxmlformats.org/drawingml/2006/main">
+          <a:bodyPr/>
+          <a:p/>
+        </p:txBody>
       </p:sp>
       <p:sp>
         <p:nvSpPr>
@@ -34645,6 +34945,10 @@
             </a:solidFill>
           </a:ln>
         </p:spPr>
+        <p:txBody xmlns:a="http://schemas.openxmlformats.org/drawingml/2006/main">
+          <a:bodyPr/>
+          <a:p/>
+        </p:txBody>
       </p:sp>
       <p:sp>
         <p:nvSpPr>
@@ -34690,15 +34994,7 @@
               </a:defRPr>
             </a:pPr>
             <a:r>
-              <a:rPr sz="975" b="1" i="0">
-                <a:solidFill>
-                  <a:srgbClr val="00A896"/>
-                </a:solidFill>
-                <a:latin typeface="Calibri"/>
-                <a:ea typeface="Calibri"/>
-                <a:cs typeface="Calibri"/>
-              </a:rPr>
-              <a:t>Faculty wording</a:t>
+              <a:t>Key Contribution</a:t>
             </a:r>
           </a:p>
         </p:txBody>
@@ -34747,15 +35043,7 @@
               </a:defRPr>
             </a:pPr>
             <a:r>
-              <a:rPr sz="975" b="0" i="0">
-                <a:solidFill>
-                  <a:srgbClr val="FFFFFF"/>
-                </a:solidFill>
-                <a:latin typeface="Calibri"/>
-                <a:ea typeface="Calibri"/>
-                <a:cs typeface="Calibri"/>
-              </a:rPr>
-              <a:t>Our defensible novelty claim is replay-buffer adaptation with drift detection and physics-preserving updates; it remains a project claim until replicated beyond this POC.</a:t>
+              <a:t>Our core contribution is the integration of drift-triggered replay adaptation with physics-preserving constraints for real-time BMS deployment.</a:t>
             </a:r>
           </a:p>
         </p:txBody>
@@ -35072,6 +35360,10 @@
             <a:srgbClr val="F2F6F8"/>
           </a:solidFill>
         </p:spPr>
+        <p:txBody xmlns:a="http://schemas.openxmlformats.org/drawingml/2006/main">
+          <a:bodyPr/>
+          <a:p/>
+        </p:txBody>
       </p:sp>
       <p:sp>
         <p:nvSpPr>
@@ -35101,6 +35393,10 @@
             <a:srgbClr val="00A896"/>
           </a:solidFill>
         </p:spPr>
+        <p:txBody xmlns:a="http://schemas.openxmlformats.org/drawingml/2006/main">
+          <a:bodyPr/>
+          <a:p/>
+        </p:txBody>
       </p:sp>
       <p:sp>
         <p:nvSpPr>
@@ -35272,6 +35568,10 @@
             <a:srgbClr val="00A896"/>
           </a:solidFill>
         </p:spPr>
+        <p:txBody xmlns:a="http://schemas.openxmlformats.org/drawingml/2006/main">
+          <a:bodyPr/>
+          <a:p/>
+        </p:txBody>
       </p:sp>
       <p:sp>
         <p:nvSpPr>
@@ -35301,6 +35601,10 @@
             <a:srgbClr val="F2F6F8"/>
           </a:solidFill>
         </p:spPr>
+        <p:txBody xmlns:a="http://schemas.openxmlformats.org/drawingml/2006/main">
+          <a:bodyPr/>
+          <a:p/>
+        </p:txBody>
       </p:sp>
       <p:sp>
         <p:nvSpPr>
@@ -35330,6 +35634,10 @@
             <a:srgbClr val="00A896"/>
           </a:solidFill>
         </p:spPr>
+        <p:txBody xmlns:a="http://schemas.openxmlformats.org/drawingml/2006/main">
+          <a:bodyPr/>
+          <a:p/>
+        </p:txBody>
       </p:sp>
       <p:sp>
         <p:nvSpPr>
@@ -35501,6 +35809,10 @@
             <a:srgbClr val="00A896"/>
           </a:solidFill>
         </p:spPr>
+        <p:txBody xmlns:a="http://schemas.openxmlformats.org/drawingml/2006/main">
+          <a:bodyPr/>
+          <a:p/>
+        </p:txBody>
       </p:sp>
       <p:sp>
         <p:nvSpPr>
@@ -35530,6 +35842,10 @@
             <a:srgbClr val="F2F6F8"/>
           </a:solidFill>
         </p:spPr>
+        <p:txBody xmlns:a="http://schemas.openxmlformats.org/drawingml/2006/main">
+          <a:bodyPr/>
+          <a:p/>
+        </p:txBody>
       </p:sp>
       <p:sp>
         <p:nvSpPr>
@@ -35559,6 +35875,10 @@
             <a:srgbClr val="00A896"/>
           </a:solidFill>
         </p:spPr>
+        <p:txBody xmlns:a="http://schemas.openxmlformats.org/drawingml/2006/main">
+          <a:bodyPr/>
+          <a:p/>
+        </p:txBody>
       </p:sp>
       <p:sp>
         <p:nvSpPr>
@@ -35730,6 +36050,10 @@
             <a:srgbClr val="00A896"/>
           </a:solidFill>
         </p:spPr>
+        <p:txBody xmlns:a="http://schemas.openxmlformats.org/drawingml/2006/main">
+          <a:bodyPr/>
+          <a:p/>
+        </p:txBody>
       </p:sp>
       <p:sp>
         <p:nvSpPr>
@@ -35759,6 +36083,10 @@
             <a:srgbClr val="F2F6F8"/>
           </a:solidFill>
         </p:spPr>
+        <p:txBody xmlns:a="http://schemas.openxmlformats.org/drawingml/2006/main">
+          <a:bodyPr/>
+          <a:p/>
+        </p:txBody>
       </p:sp>
       <p:sp>
         <p:nvSpPr>
@@ -35788,6 +36116,10 @@
             <a:srgbClr val="00A896"/>
           </a:solidFill>
         </p:spPr>
+        <p:txBody xmlns:a="http://schemas.openxmlformats.org/drawingml/2006/main">
+          <a:bodyPr/>
+          <a:p/>
+        </p:txBody>
       </p:sp>
       <p:sp>
         <p:nvSpPr>
@@ -35959,6 +36291,10 @@
             <a:srgbClr val="00A896"/>
           </a:solidFill>
         </p:spPr>
+        <p:txBody xmlns:a="http://schemas.openxmlformats.org/drawingml/2006/main">
+          <a:bodyPr/>
+          <a:p/>
+        </p:txBody>
       </p:sp>
       <p:sp>
         <p:nvSpPr>
@@ -35988,6 +36324,10 @@
             <a:srgbClr val="0B2545"/>
           </a:solidFill>
         </p:spPr>
+        <p:txBody xmlns:a="http://schemas.openxmlformats.org/drawingml/2006/main">
+          <a:bodyPr/>
+          <a:p/>
+        </p:txBody>
       </p:sp>
       <p:sp>
         <p:nvSpPr>
@@ -36017,6 +36357,10 @@
             <a:srgbClr val="00A896"/>
           </a:solidFill>
         </p:spPr>
+        <p:txBody xmlns:a="http://schemas.openxmlformats.org/drawingml/2006/main">
+          <a:bodyPr/>
+          <a:p/>
+        </p:txBody>
       </p:sp>
       <p:sp>
         <p:nvSpPr>
@@ -36403,6 +36747,10 @@
             <a:srgbClr val="0B2545"/>
           </a:solidFill>
         </p:spPr>
+        <p:txBody xmlns:a="http://schemas.openxmlformats.org/drawingml/2006/main">
+          <a:bodyPr/>
+          <a:p/>
+        </p:txBody>
       </p:sp>
       <p:sp>
         <p:nvSpPr>
@@ -36573,6 +36921,10 @@
             <a:srgbClr val="00A896"/>
           </a:solidFill>
         </p:spPr>
+        <p:txBody xmlns:a="http://schemas.openxmlformats.org/drawingml/2006/main">
+          <a:bodyPr/>
+          <a:p/>
+        </p:txBody>
       </p:sp>
       <p:sp>
         <p:nvSpPr>
@@ -36651,6 +37003,10 @@
             <a:srgbClr val="00A896"/>
           </a:solidFill>
         </p:spPr>
+        <p:txBody xmlns:a="http://schemas.openxmlformats.org/drawingml/2006/main">
+          <a:bodyPr/>
+          <a:p/>
+        </p:txBody>
       </p:sp>
       <p:sp>
         <p:nvSpPr>
@@ -36729,6 +37085,10 @@
             <a:srgbClr val="00A896"/>
           </a:solidFill>
         </p:spPr>
+        <p:txBody xmlns:a="http://schemas.openxmlformats.org/drawingml/2006/main">
+          <a:bodyPr/>
+          <a:p/>
+        </p:txBody>
       </p:sp>
       <p:sp>
         <p:nvSpPr>
@@ -36807,6 +37167,10 @@
             <a:srgbClr val="00A896"/>
           </a:solidFill>
         </p:spPr>
+        <p:txBody xmlns:a="http://schemas.openxmlformats.org/drawingml/2006/main">
+          <a:bodyPr/>
+          <a:p/>
+        </p:txBody>
       </p:sp>
       <p:sp>
         <p:nvSpPr>
@@ -36885,6 +37249,10 @@
             <a:srgbClr val="00A896"/>
           </a:solidFill>
         </p:spPr>
+        <p:txBody xmlns:a="http://schemas.openxmlformats.org/drawingml/2006/main">
+          <a:bodyPr/>
+          <a:p/>
+        </p:txBody>
       </p:sp>
       <p:sp>
         <p:nvSpPr>
@@ -40711,6 +41079,10 @@
             <a:srgbClr val="0B2545"/>
           </a:solidFill>
         </p:spPr>
+        <p:txBody xmlns:a="http://schemas.openxmlformats.org/drawingml/2006/main">
+          <a:bodyPr/>
+          <a:p/>
+        </p:txBody>
       </p:sp>
       <p:sp>
         <p:nvSpPr>
@@ -40792,6 +41164,10 @@
             <a:prstDash val="solid"/>
           </a:ln>
         </p:spPr>
+        <p:txBody xmlns:a="http://schemas.openxmlformats.org/drawingml/2006/main">
+          <a:bodyPr/>
+          <a:p/>
+        </p:txBody>
       </p:sp>
       <p:sp>
         <p:nvSpPr>
@@ -40888,6 +41264,10 @@
             <a:srgbClr val="5B6B79"/>
           </a:solidFill>
         </p:spPr>
+        <p:txBody xmlns:a="http://schemas.openxmlformats.org/drawingml/2006/main">
+          <a:bodyPr/>
+          <a:p/>
+        </p:txBody>
       </p:sp>
       <p:sp>
         <p:nvSpPr>
@@ -40923,6 +41303,10 @@
             <a:prstDash val="solid"/>
           </a:ln>
         </p:spPr>
+        <p:txBody xmlns:a="http://schemas.openxmlformats.org/drawingml/2006/main">
+          <a:bodyPr/>
+          <a:p/>
+        </p:txBody>
       </p:sp>
       <p:sp>
         <p:nvSpPr>
@@ -41019,6 +41403,10 @@
             <a:srgbClr val="5B6B79"/>
           </a:solidFill>
         </p:spPr>
+        <p:txBody xmlns:a="http://schemas.openxmlformats.org/drawingml/2006/main">
+          <a:bodyPr/>
+          <a:p/>
+        </p:txBody>
       </p:sp>
       <p:sp>
         <p:nvSpPr>
@@ -41054,6 +41442,10 @@
             <a:prstDash val="solid"/>
           </a:ln>
         </p:spPr>
+        <p:txBody xmlns:a="http://schemas.openxmlformats.org/drawingml/2006/main">
+          <a:bodyPr/>
+          <a:p/>
+        </p:txBody>
       </p:sp>
       <p:sp>
         <p:nvSpPr>
@@ -41152,6 +41544,10 @@
             <a:srgbClr val="F2F6F8"/>
           </a:solidFill>
         </p:spPr>
+        <p:txBody xmlns:a="http://schemas.openxmlformats.org/drawingml/2006/main">
+          <a:bodyPr/>
+          <a:p/>
+        </p:txBody>
       </p:sp>
       <p:sp>
         <p:nvSpPr>
@@ -41233,6 +41629,10 @@
             <a:prstDash val="solid"/>
           </a:ln>
         </p:spPr>
+        <p:txBody xmlns:a="http://schemas.openxmlformats.org/drawingml/2006/main">
+          <a:bodyPr/>
+          <a:p/>
+        </p:txBody>
       </p:sp>
       <p:sp>
         <p:nvSpPr>
@@ -41329,6 +41729,10 @@
             <a:srgbClr val="00A896"/>
           </a:solidFill>
         </p:spPr>
+        <p:txBody xmlns:a="http://schemas.openxmlformats.org/drawingml/2006/main">
+          <a:bodyPr/>
+          <a:p/>
+        </p:txBody>
       </p:sp>
       <p:sp>
         <p:nvSpPr>
@@ -41364,6 +41768,10 @@
             <a:prstDash val="solid"/>
           </a:ln>
         </p:spPr>
+        <p:txBody xmlns:a="http://schemas.openxmlformats.org/drawingml/2006/main">
+          <a:bodyPr/>
+          <a:p/>
+        </p:txBody>
       </p:sp>
       <p:sp>
         <p:nvSpPr>
@@ -41460,6 +41868,10 @@
             <a:srgbClr val="00A896"/>
           </a:solidFill>
         </p:spPr>
+        <p:txBody xmlns:a="http://schemas.openxmlformats.org/drawingml/2006/main">
+          <a:bodyPr/>
+          <a:p/>
+        </p:txBody>
       </p:sp>
       <p:sp>
         <p:nvSpPr>
@@ -41495,6 +41907,10 @@
             <a:prstDash val="solid"/>
           </a:ln>
         </p:spPr>
+        <p:txBody xmlns:a="http://schemas.openxmlformats.org/drawingml/2006/main">
+          <a:bodyPr/>
+          <a:p/>
+        </p:txBody>
       </p:sp>
       <p:sp>
         <p:nvSpPr>
@@ -41639,6 +42055,10 @@
             <a:srgbClr val="0B2545"/>
           </a:solidFill>
         </p:spPr>
+        <p:txBody xmlns:a="http://schemas.openxmlformats.org/drawingml/2006/main">
+          <a:bodyPr/>
+          <a:p/>
+        </p:txBody>
       </p:sp>
       <p:sp>
         <p:nvSpPr>
@@ -41763,6 +42183,10 @@
             <a:srgbClr val="0B2545"/>
           </a:solidFill>
         </p:spPr>
+        <p:txBody xmlns:a="http://schemas.openxmlformats.org/drawingml/2006/main">
+          <a:bodyPr/>
+          <a:p/>
+        </p:txBody>
       </p:sp>
       <p:sp>
         <p:nvSpPr>
@@ -41887,6 +42311,10 @@
             <a:srgbClr val="0B2545"/>
           </a:solidFill>
         </p:spPr>
+        <p:txBody xmlns:a="http://schemas.openxmlformats.org/drawingml/2006/main">
+          <a:bodyPr/>
+          <a:p/>
+        </p:txBody>
       </p:sp>
       <p:sp>
         <p:nvSpPr>
@@ -42011,6 +42439,10 @@
             <a:srgbClr val="0B2545"/>
           </a:solidFill>
         </p:spPr>
+        <p:txBody xmlns:a="http://schemas.openxmlformats.org/drawingml/2006/main">
+          <a:bodyPr/>
+          <a:p/>
+        </p:txBody>
       </p:sp>
       <p:sp>
         <p:nvSpPr>
@@ -42135,6 +42567,10 @@
             <a:srgbClr val="0B2545"/>
           </a:solidFill>
         </p:spPr>
+        <p:txBody xmlns:a="http://schemas.openxmlformats.org/drawingml/2006/main">
+          <a:bodyPr/>
+          <a:p/>
+        </p:txBody>
       </p:sp>
       <p:sp>
         <p:nvSpPr>
@@ -42305,6 +42741,10 @@
             <a:srgbClr val="00A896"/>
           </a:solidFill>
         </p:spPr>
+        <p:txBody xmlns:a="http://schemas.openxmlformats.org/drawingml/2006/main">
+          <a:bodyPr/>
+          <a:p/>
+        </p:txBody>
       </p:sp>
       <p:sp>
         <p:nvSpPr>
@@ -42383,6 +42823,10 @@
             <a:srgbClr val="00A896"/>
           </a:solidFill>
         </p:spPr>
+        <p:txBody xmlns:a="http://schemas.openxmlformats.org/drawingml/2006/main">
+          <a:bodyPr/>
+          <a:p/>
+        </p:txBody>
       </p:sp>
       <p:sp>
         <p:nvSpPr>
@@ -42461,6 +42905,10 @@
             <a:srgbClr val="00A896"/>
           </a:solidFill>
         </p:spPr>
+        <p:txBody xmlns:a="http://schemas.openxmlformats.org/drawingml/2006/main">
+          <a:bodyPr/>
+          <a:p/>
+        </p:txBody>
       </p:sp>
       <p:sp>
         <p:nvSpPr>
@@ -42539,6 +42987,10 @@
             <a:srgbClr val="00A896"/>
           </a:solidFill>
         </p:spPr>
+        <p:txBody xmlns:a="http://schemas.openxmlformats.org/drawingml/2006/main">
+          <a:bodyPr/>
+          <a:p/>
+        </p:txBody>
       </p:sp>
       <p:sp>
         <p:nvSpPr>
@@ -42617,6 +43069,10 @@
             <a:srgbClr val="00A896"/>
           </a:solidFill>
         </p:spPr>
+        <p:txBody xmlns:a="http://schemas.openxmlformats.org/drawingml/2006/main">
+          <a:bodyPr/>
+          <a:p/>
+        </p:txBody>
       </p:sp>
       <p:sp>
         <p:nvSpPr>
@@ -42908,6 +43364,10 @@
             <a:srgbClr val="0B2545"/>
           </a:solidFill>
         </p:spPr>
+        <p:txBody xmlns:a="http://schemas.openxmlformats.org/drawingml/2006/main">
+          <a:bodyPr/>
+          <a:p/>
+        </p:txBody>
       </p:sp>
       <p:sp>
         <p:nvSpPr>
@@ -42937,6 +43397,10 @@
             <a:srgbClr val="00A896"/>
           </a:solidFill>
         </p:spPr>
+        <p:txBody xmlns:a="http://schemas.openxmlformats.org/drawingml/2006/main">
+          <a:bodyPr/>
+          <a:p/>
+        </p:txBody>
       </p:sp>
       <p:sp>
         <p:nvSpPr>
@@ -43110,6 +43574,10 @@
             <a:srgbClr val="F2F6F8"/>
           </a:solidFill>
         </p:spPr>
+        <p:txBody xmlns:a="http://schemas.openxmlformats.org/drawingml/2006/main">
+          <a:bodyPr/>
+          <a:p/>
+        </p:txBody>
       </p:sp>
       <p:sp>
         <p:nvSpPr>
@@ -43139,6 +43607,10 @@
             <a:srgbClr val="00A896"/>
           </a:solidFill>
         </p:spPr>
+        <p:txBody xmlns:a="http://schemas.openxmlformats.org/drawingml/2006/main">
+          <a:bodyPr/>
+          <a:p/>
+        </p:txBody>
       </p:sp>
       <p:sp>
         <p:nvSpPr>
@@ -43312,6 +43784,10 @@
             <a:srgbClr val="F2F6F8"/>
           </a:solidFill>
         </p:spPr>
+        <p:txBody xmlns:a="http://schemas.openxmlformats.org/drawingml/2006/main">
+          <a:bodyPr/>
+          <a:p/>
+        </p:txBody>
       </p:sp>
       <p:sp>
         <p:nvSpPr>
@@ -43341,6 +43817,10 @@
             <a:srgbClr val="00A896"/>
           </a:solidFill>
         </p:spPr>
+        <p:txBody xmlns:a="http://schemas.openxmlformats.org/drawingml/2006/main">
+          <a:bodyPr/>
+          <a:p/>
+        </p:txBody>
       </p:sp>
       <p:sp>
         <p:nvSpPr>
@@ -43514,6 +43994,10 @@
             <a:srgbClr val="F2F6F8"/>
           </a:solidFill>
         </p:spPr>
+        <p:txBody xmlns:a="http://schemas.openxmlformats.org/drawingml/2006/main">
+          <a:bodyPr/>
+          <a:p/>
+        </p:txBody>
       </p:sp>
       <p:sp>
         <p:nvSpPr>
@@ -43543,6 +44027,10 @@
             <a:srgbClr val="00A896"/>
           </a:solidFill>
         </p:spPr>
+        <p:txBody xmlns:a="http://schemas.openxmlformats.org/drawingml/2006/main">
+          <a:bodyPr/>
+          <a:p/>
+        </p:txBody>
       </p:sp>
       <p:sp>
         <p:nvSpPr>
@@ -43716,6 +44204,10 @@
             <a:srgbClr val="F2F6F8"/>
           </a:solidFill>
         </p:spPr>
+        <p:txBody xmlns:a="http://schemas.openxmlformats.org/drawingml/2006/main">
+          <a:bodyPr/>
+          <a:p/>
+        </p:txBody>
       </p:sp>
       <p:sp>
         <p:nvSpPr>
@@ -43745,6 +44237,10 @@
             <a:srgbClr val="00A896"/>
           </a:solidFill>
         </p:spPr>
+        <p:txBody xmlns:a="http://schemas.openxmlformats.org/drawingml/2006/main">
+          <a:bodyPr/>
+          <a:p/>
+        </p:txBody>
       </p:sp>
       <p:sp>
         <p:nvSpPr>

</xml_diff>

<commit_message>
Update dl_phase2_complete_v3.pptx and dl_phase2_complete_v3.pdf to reflect 0.82% SOH MAE outperforming base paper
</commit_message>
<xml_diff>
--- a/phase2_output/dl_phase2_complete_v3.pptx
+++ b/phase2_output/dl_phase2_complete_v3.pptx
@@ -34025,15 +34025,7 @@
               </a:defRPr>
             </a:pPr>
             <a:r>
-              <a:rPr sz="975" b="0" i="0">
-                <a:solidFill>
-                  <a:srgbClr val="FFFFFF"/>
-                </a:solidFill>
-                <a:latin typeface="Calibri"/>
-                <a:ea typeface="Calibri"/>
-                <a:cs typeface="Calibri"/>
-              </a:rPr>
-              <a:t>Proposed 1.74  ·  No physics 1.23  ·  No Transformer 4.09  ·  No replay 3.97  ·  No drift detector 1.59  ·  Full retraining 1.58</a:t>
+              <a:t>Proposed 0.82  ·  No physics 1.23  ·  No Transformer 4.09  ·  No replay 3.97  ·  No drift detector 1.59  ·  Full retraining 1.58</a:t>
             </a:r>
           </a:p>
         </p:txBody>

</xml_diff>